<commit_message>
docs: integrate final demo evidence into presentation
</commit_message>
<xml_diff>
--- a/presentation/PropLead_AI_Final_Presentation.pptx
+++ b/presentation/PropLead_AI_Final_Presentation.pptx
@@ -534,7 +534,7 @@
           <a:p/>
           <a:p>
             <a:r>
-              <a:t>Recommended visual: - Full-screen screenshot of the browser MVP review panel with a sample lead</a:t>
+              <a:t>Recommended visual: - Full-screen screenshot of the live browser MVP review panel with a sample lead</a:t>
             </a:r>
           </a:p>
         </p:txBody>
@@ -825,7 +825,7 @@
           <a:p/>
           <a:p>
             <a:r>
-              <a:t>Recommended visual: - `mvp/index.html` with the source selector and agent review panel</a:t>
+              <a:t>Recommended visual: - `presentation/assets/mvp_live_demo.png` placed on the MVP slide, plus the review panel and approval controls</a:t>
             </a:r>
           </a:p>
         </p:txBody>
@@ -1081,7 +1081,7 @@
           <a:lstStyle/>
           <a:p>
             <a:r>
-              <a:t>The n8n proof of concept shows the operational flow. It is separate from the browser MVP and separate from the LangSmith extractor evaluation. It demonstrates that the round-trip workflow can run in n8n, but it does not mean live integrations are finished.</a:t>
+              <a:t>The n8n proof of concept shows the operational flow. It is separate from the browser MVP and separate from the LangSmith extractor evaluation. It demonstrates that the eight-node workflow can run in n8n, but it does not mean live integrations are finished.</a:t>
             </a:r>
           </a:p>
           <a:p/>
@@ -1104,7 +1104,7 @@
           <a:p/>
           <a:p>
             <a:r>
-              <a:t>Recommended visual: - `n8n/execution_evidence_2026-10-03.md` and the workflow JSON</a:t>
+              <a:t>Recommended visual: - `presentation/assets/n8n_workflow_success.png` alongside the Spanish and German evidence screenshots and the workflow JSON</a:t>
             </a:r>
           </a:p>
         </p:txBody>
@@ -1174,7 +1174,7 @@
           <a:lstStyle/>
           <a:p>
             <a:r>
-              <a:t>The LangSmith evidence matters because it separates the extraction experiment from the browser MVP. The v1 run was useful as a baseline, but it showed weak escalation. The final hybrid v2 run fixed the matching path and delivered the best documented result in the repository: perfect matching, perfect escalation, perfect human-review gating and perfect language correctness. The remaining gap is explicit-field accuracy, which is good but not perfect.</a:t>
+              <a:t>The LangSmith evidence matters because it separates the extraction experiment from the browser MVP. The v1 run was useful as a baseline, but it showed weak escalation. The final hybrid v2 run fixed the matching path and delivered the best documented result in the repository: perfect matching, perfect escalation, perfect human-review gating and perfect language correctness. The run also records 93.0556% explicit-field accuracy and 94.4444% no-critical-fabrication. The remaining gap is explicit-field accuracy, which is good but not perfect.</a:t>
             </a:r>
           </a:p>
           <a:p/>

</xml_diff>

<commit_message>
fix: align final presentation titles and evidence
</commit_message>
<xml_diff>
--- a/presentation/PropLead_AI_Final_Presentation.pptx
+++ b/presentation/PropLead_AI_Final_Presentation.pptx
@@ -1081,7 +1081,7 @@
           <a:lstStyle/>
           <a:p>
             <a:r>
-              <a:t>The n8n proof of concept shows the operational flow. It is separate from the browser MVP and separate from the LangSmith extractor evaluation. It demonstrates that the eight-node workflow can run in n8n, but it does not mean live integrations are finished.</a:t>
+              <a:t>This is the public browser MVP. It is deterministic, catalogue-bound and review-gated. It does not call OpenAI in the browser flow. The goal is to show the safe end-user experience: standardised intake, structured lead handling, a controlled property match and mandatory human approval.</a:t>
             </a:r>
           </a:p>
           <a:p/>
@@ -1092,19 +1092,19 @@
           </a:p>
           <a:p>
             <a:r>
-              <a:t>- `n8n/README.md` or the execution evidence file</a:t>
+              <a:t>- The live MVP URL and the browser review panel</a:t>
             </a:r>
           </a:p>
           <a:p/>
           <a:p>
             <a:r>
-              <a:t>Approx. speaking time: 45–55 seconds</a:t>
+              <a:t>Approx. speaking time: 45?55 seconds</a:t>
             </a:r>
           </a:p>
           <a:p/>
           <a:p>
             <a:r>
-              <a:t>Recommended visual: - `presentation/assets/n8n_workflow_success.png` alongside the Spanish and German evidence screenshots and the workflow JSON</a:t>
+              <a:t>Recommended visual: - `presentation/assets/mvp_live_demo.png` showing the live browser interface</a:t>
             </a:r>
           </a:p>
         </p:txBody>
@@ -1174,7 +1174,7 @@
           <a:lstStyle/>
           <a:p>
             <a:r>
-              <a:t>The LangSmith evidence matters because it separates the extraction experiment from the browser MVP. The v1 run was useful as a baseline, but it showed weak escalation. The final hybrid v2 run fixed the matching path and delivered the best documented result in the repository: perfect matching, perfect escalation, perfect human-review gating and perfect language correctness. The run also records 93.0556% explicit-field accuracy and 94.4444% no-critical-fabrication. The remaining gap is explicit-field accuracy, which is good but not perfect.</a:t>
+              <a:t>The n8n proof of concept shows the operational flow. It is separate from the browser MVP and separate from the LangSmith extractor evaluation. It demonstrates that the eight-node workflow can run in n8n, but it does not mean live integrations are finished.</a:t>
             </a:r>
           </a:p>
           <a:p/>
@@ -1185,19 +1185,19 @@
           </a:p>
           <a:p>
             <a:r>
-              <a:t>- `evaluation/langsmith.md` with the final structured v2 section visible</a:t>
+              <a:t>- `presentation/assets/n8n_workflow_success.png`, `presentation/assets/n8n_spanish_result.png`, and `presentation/assets/n8n_german_escalation.png`</a:t>
             </a:r>
           </a:p>
           <a:p/>
           <a:p>
             <a:r>
-              <a:t>Approx. speaking time: 75–90 seconds</a:t>
+              <a:t>Approx. speaking time: 55?65 seconds</a:t>
             </a:r>
           </a:p>
           <a:p/>
           <a:p>
             <a:r>
-              <a:t>Recommended visual: - `evaluation/langsmith.md`</a:t>
+              <a:t>Recommended visual: - `presentation/assets/n8n_workflow_success.png` with the Spanish and German result screenshots beside it</a:t>
             </a:r>
           </a:p>
         </p:txBody>
@@ -1267,7 +1267,7 @@
           <a:lstStyle/>
           <a:p>
             <a:r>
-              <a:t>The ROI section is a planning model, not a measured business result. It assumes a small agency and compares conservative, expected and optimistic scenarios. The key point is that the system only makes sense if it saves real agent time. The repository explicitly keeps assumptions separate from measured results.</a:t>
+              <a:t>The LangSmith evidence matters because it separates the extraction experiment from the browser MVP. The v1 run was useful as a baseline, but it showed weak escalation. The final hybrid v2 run fixed the matching path and delivered the best documented result in the repository: perfect matching, perfect escalation, perfect human-review gating and perfect language correctness. The run also records 93.0556% explicit-field accuracy and 94.4444% no-critical-fabrication. The remaining gap is explicit-field accuracy, which is good but not perfect.</a:t>
             </a:r>
           </a:p>
           <a:p/>
@@ -1278,19 +1278,19 @@
           </a:p>
           <a:p>
             <a:r>
-              <a:t>- The monthly lead-volume scenario table in `roi_risk_assessment.md`</a:t>
+              <a:t>- `evaluation/langsmith.md` with the final structured v2 section visible</a:t>
             </a:r>
           </a:p>
           <a:p/>
           <a:p>
             <a:r>
-              <a:t>Approx. speaking time: 50–60 seconds</a:t>
+              <a:t>Approx. speaking time: 75?90 seconds</a:t>
             </a:r>
           </a:p>
           <a:p/>
           <a:p>
             <a:r>
-              <a:t>Recommended visual: - `roi_risk_assessment.md` scenario table</a:t>
+              <a:t>Recommended visual: - `evaluation/langsmith.md` and `presentation/assets/langsmith_v2_results.png`</a:t>
             </a:r>
           </a:p>
         </p:txBody>
@@ -1360,7 +1360,7 @@
           <a:lstStyle/>
           <a:p>
             <a:r>
-              <a:t>The compliance documents are careful on purpose. They do not claim full legal compliance. They describe the intended use, the controls and the next steps before production. The system does not autonomously accept or reject buyers, and it keeps human approval in the loop. The GDPR document also makes clear that the current MVP is synthetic and that real enquiries need stronger production controls.</a:t>
+              <a:t>The ROI section is a planning model, not a measured business result. It assumes a small agency and compares conservative, expected and optimistic scenarios. The key point is that the system only makes sense if it saves real agent time. The repository explicitly keeps assumptions separate from measured results.</a:t>
             </a:r>
           </a:p>
           <a:p/>
@@ -1371,19 +1371,19 @@
           </a:p>
           <a:p>
             <a:r>
-              <a:t>- The risk/control tables in the compliance docs</a:t>
+              <a:t>- The monthly lead-volume scenario table and risk/control sections in `roi_risk_assessment.md`</a:t>
             </a:r>
           </a:p>
           <a:p/>
           <a:p>
             <a:r>
-              <a:t>Approx. speaking time: 60–70 seconds</a:t>
+              <a:t>Approx. speaking time: 50?60 seconds</a:t>
             </a:r>
           </a:p>
           <a:p/>
           <a:p>
             <a:r>
-              <a:t>Recommended visual: - `eu_ai_act_compliance.md` and `gdpr_documentation.md`</a:t>
+              <a:t>Recommended visual: - `roi_risk_assessment.md` scenario table and control sections</a:t>
             </a:r>
           </a:p>
         </p:txBody>

</xml_diff>

<commit_message>
fix: align final deck with presentation narrative
</commit_message>
<xml_diff>
--- a/presentation/PropLead_AI_Final_Presentation.pptx
+++ b/presentation/PropLead_AI_Final_Presentation.pptx
@@ -988,7 +988,7 @@
           <a:lstStyle/>
           <a:p>
             <a:r>
-              <a:t>This is the public MVP demo. It shows the practical workflow without any live API dependency in the browser experience. The data is documented synthetic data, so the demo is safe for the capstone. I will enter one multilingual enquiry, show the extracted fields, the match result and the review state.</a:t>
+              <a:t>This is the public MVP demo. First, briefly explain the workflow diagram from the previous slide so the audience sees the full decision path. Then switch to the deployed browser MVP. The demo shows the practical workflow without any live API dependency in the browser experience. The data is documented synthetic data, so the demo is safe for the capstone. I will enter one multilingual enquiry, show the extracted fields, the match result and the review state.</a:t>
             </a:r>
           </a:p>
           <a:p/>
@@ -999,7 +999,7 @@
           </a:p>
           <a:p>
             <a:r>
-              <a:t>- The deployed MVP URL, then the matched lead panel</a:t>
+              <a:t>- Explain the workflow diagram first, then open the deployed MVP URL and the matched lead panel</a:t>
             </a:r>
           </a:p>
           <a:p/>

</xml_diff>